<commit_message>
Update published course materials
</commit_message>
<xml_diff>
--- a/lessons/ПрИн_Л1_2026_INTRO.pptx
+++ b/lessons/ПрИн_Л1_2026_INTRO.pptx
@@ -119,1590 +119,6 @@
     </a:lvl9pPr>
   </p:defaultTextStyle>
 </p:presentation>
-</file>
-
-<file path=ppt/notesMasters/notesMaster1.xml><?xml version="1.0" encoding="utf-8"?>
-<p:notesMaster xmlns:a="http://schemas.openxmlformats.org/drawingml/2006/main" xmlns:p="http://schemas.openxmlformats.org/presentationml/2006/main" xmlns:r="http://schemas.openxmlformats.org/officeDocument/2006/relationships">
-  <p:cSld>
-    <p:bg>
-      <p:bgRef idx="1001">
-        <a:schemeClr val="bg1"/>
-      </p:bgRef>
-    </p:bg>
-    <p:spTree>
-      <p:nvGrpSpPr>
-        <p:cNvPr id="1" name=""/>
-        <p:cNvGrpSpPr/>
-        <p:nvPr/>
-      </p:nvGrpSpPr>
-      <p:grpSpPr>
-        <a:xfrm>
-          <a:off x="0" y="0"/>
-          <a:ext cx="0" cy="0"/>
-          <a:chOff x="0" y="0"/>
-          <a:chExt cx="0" cy="0"/>
-        </a:xfrm>
-      </p:grpSpPr>
-      <p:sp>
-        <p:nvSpPr>
-          <p:cNvPr id="2" name="Header Placeholder 1"/>
-          <p:cNvSpPr>
-            <a:spLocks noGrp="1"/>
-          </p:cNvSpPr>
-          <p:nvPr>
-            <p:ph type="hdr" sz="quarter"/>
-          </p:nvPr>
-        </p:nvSpPr>
-        <p:spPr>
-          <a:xfrm>
-            <a:off x="0" y="0"/>
-            <a:ext cx="2971800" cy="457200"/>
-          </a:xfrm>
-          <a:prstGeom prst="rect">
-            <a:avLst/>
-          </a:prstGeom>
-        </p:spPr>
-        <p:txBody>
-          <a:bodyPr vert="horz" lIns="91440" tIns="45720" rIns="91440" bIns="45720" rtlCol="0"/>
-          <a:lstStyle>
-            <a:lvl1pPr algn="l">
-              <a:defRPr sz="1200"/>
-            </a:lvl1pPr>
-          </a:lstStyle>
-          <a:p>
-            <a:endParaRPr lang="en-US"/>
-          </a:p>
-        </p:txBody>
-      </p:sp>
-      <p:sp>
-        <p:nvSpPr>
-          <p:cNvPr id="3" name="Date Placeholder 2"/>
-          <p:cNvSpPr>
-            <a:spLocks noGrp="1"/>
-          </p:cNvSpPr>
-          <p:nvPr>
-            <p:ph type="dt" idx="1"/>
-          </p:nvPr>
-        </p:nvSpPr>
-        <p:spPr>
-          <a:xfrm>
-            <a:off x="3884613" y="0"/>
-            <a:ext cx="2971800" cy="457200"/>
-          </a:xfrm>
-          <a:prstGeom prst="rect">
-            <a:avLst/>
-          </a:prstGeom>
-        </p:spPr>
-        <p:txBody>
-          <a:bodyPr vert="horz" lIns="91440" tIns="45720" rIns="91440" bIns="45720" rtlCol="0"/>
-          <a:lstStyle>
-            <a:lvl1pPr algn="r">
-              <a:defRPr sz="1200"/>
-            </a:lvl1pPr>
-          </a:lstStyle>
-          <a:p>
-            <a:fld id="{0F89C1C7-3DCD-1040-A9CF-14679D8B5DDD}" type="datetimeFigureOut">
-              <a:rPr lang="en-US" smtClean="0"/>
-              <a:t>10/17/16</a:t>
-            </a:fld>
-            <a:endParaRPr lang="en-US"/>
-          </a:p>
-        </p:txBody>
-      </p:sp>
-      <p:sp>
-        <p:nvSpPr>
-          <p:cNvPr id="4" name="Slide Image Placeholder 3"/>
-          <p:cNvSpPr>
-            <a:spLocks noGrp="1" noRot="1" noChangeAspect="1"/>
-          </p:cNvSpPr>
-          <p:nvPr>
-            <p:ph type="sldImg" idx="2"/>
-          </p:nvPr>
-        </p:nvSpPr>
-        <p:spPr>
-          <a:xfrm>
-            <a:off x="1143000" y="685800"/>
-            <a:ext cx="4572000" cy="3429000"/>
-          </a:xfrm>
-          <a:prstGeom prst="rect">
-            <a:avLst/>
-          </a:prstGeom>
-          <a:noFill/>
-          <a:ln w="12700">
-            <a:solidFill>
-              <a:prstClr val="black"/>
-            </a:solidFill>
-          </a:ln>
-        </p:spPr>
-        <p:txBody>
-          <a:bodyPr vert="horz" lIns="91440" tIns="45720" rIns="91440" bIns="45720" rtlCol="0" anchor="ctr"/>
-          <a:lstStyle/>
-          <a:p>
-            <a:endParaRPr lang="en-US"/>
-          </a:p>
-        </p:txBody>
-      </p:sp>
-      <p:sp>
-        <p:nvSpPr>
-          <p:cNvPr id="5" name="Notes Placeholder 4"/>
-          <p:cNvSpPr>
-            <a:spLocks noGrp="1"/>
-          </p:cNvSpPr>
-          <p:nvPr>
-            <p:ph type="body" sz="quarter" idx="3"/>
-          </p:nvPr>
-        </p:nvSpPr>
-        <p:spPr>
-          <a:xfrm>
-            <a:off x="685800" y="4343400"/>
-            <a:ext cx="5486400" cy="4114800"/>
-          </a:xfrm>
-          <a:prstGeom prst="rect">
-            <a:avLst/>
-          </a:prstGeom>
-        </p:spPr>
-        <p:txBody>
-          <a:bodyPr vert="horz" lIns="91440" tIns="45720" rIns="91440" bIns="45720" rtlCol="0"/>
-          <a:lstStyle/>
-          <a:p>
-            <a:pPr lvl="0"/>
-            <a:r>
-              <a:rPr lang="en-US" smtClean="0"/>
-              <a:t>Click to edit Master text styles</a:t>
-            </a:r>
-          </a:p>
-          <a:p>
-            <a:pPr lvl="1"/>
-            <a:r>
-              <a:rPr lang="en-US" smtClean="0"/>
-              <a:t>Second level</a:t>
-            </a:r>
-          </a:p>
-          <a:p>
-            <a:pPr lvl="2"/>
-            <a:r>
-              <a:rPr lang="en-US" smtClean="0"/>
-              <a:t>Third level</a:t>
-            </a:r>
-          </a:p>
-          <a:p>
-            <a:pPr lvl="3"/>
-            <a:r>
-              <a:rPr lang="en-US" smtClean="0"/>
-              <a:t>Fourth level</a:t>
-            </a:r>
-          </a:p>
-          <a:p>
-            <a:pPr lvl="4"/>
-            <a:r>
-              <a:rPr lang="en-US" smtClean="0"/>
-              <a:t>Fifth level</a:t>
-            </a:r>
-            <a:endParaRPr lang="en-US"/>
-          </a:p>
-        </p:txBody>
-      </p:sp>
-      <p:sp>
-        <p:nvSpPr>
-          <p:cNvPr id="6" name="Footer Placeholder 5"/>
-          <p:cNvSpPr>
-            <a:spLocks noGrp="1"/>
-          </p:cNvSpPr>
-          <p:nvPr>
-            <p:ph type="ftr" sz="quarter" idx="4"/>
-          </p:nvPr>
-        </p:nvSpPr>
-        <p:spPr>
-          <a:xfrm>
-            <a:off x="0" y="8685213"/>
-            <a:ext cx="2971800" cy="457200"/>
-          </a:xfrm>
-          <a:prstGeom prst="rect">
-            <a:avLst/>
-          </a:prstGeom>
-        </p:spPr>
-        <p:txBody>
-          <a:bodyPr vert="horz" lIns="91440" tIns="45720" rIns="91440" bIns="45720" rtlCol="0" anchor="b"/>
-          <a:lstStyle>
-            <a:lvl1pPr algn="l">
-              <a:defRPr sz="1200"/>
-            </a:lvl1pPr>
-          </a:lstStyle>
-          <a:p>
-            <a:endParaRPr lang="en-US"/>
-          </a:p>
-        </p:txBody>
-      </p:sp>
-      <p:sp>
-        <p:nvSpPr>
-          <p:cNvPr id="7" name="Slide Number Placeholder 6"/>
-          <p:cNvSpPr>
-            <a:spLocks noGrp="1"/>
-          </p:cNvSpPr>
-          <p:nvPr>
-            <p:ph type="sldNum" sz="quarter" idx="5"/>
-          </p:nvPr>
-        </p:nvSpPr>
-        <p:spPr>
-          <a:xfrm>
-            <a:off x="3884613" y="8685213"/>
-            <a:ext cx="2971800" cy="457200"/>
-          </a:xfrm>
-          <a:prstGeom prst="rect">
-            <a:avLst/>
-          </a:prstGeom>
-        </p:spPr>
-        <p:txBody>
-          <a:bodyPr vert="horz" lIns="91440" tIns="45720" rIns="91440" bIns="45720" rtlCol="0" anchor="b"/>
-          <a:lstStyle>
-            <a:lvl1pPr algn="r">
-              <a:defRPr sz="1200"/>
-            </a:lvl1pPr>
-          </a:lstStyle>
-          <a:p>
-            <a:fld id="{BB5E49A5-4136-284D-997B-48E1D791AD67}" type="slidenum">
-              <a:rPr lang="en-US" smtClean="0"/>
-              <a:t>‹#›</a:t>
-            </a:fld>
-            <a:endParaRPr lang="en-US"/>
-          </a:p>
-        </p:txBody>
-      </p:sp>
-    </p:spTree>
-    <p:extLst>
-      <p:ext uri="{BB962C8B-B14F-4D97-AF65-F5344CB8AC3E}">
-        <p14:creationId xmlns:p14="http://schemas.microsoft.com/office/powerpoint/2010/main" val="2623252185"/>
-      </p:ext>
-    </p:extLst>
-  </p:cSld>
-  <p:clrMap bg1="lt1" tx1="dk1" bg2="lt2" tx2="dk2" accent1="accent1" accent2="accent2" accent3="accent3" accent4="accent4" accent5="accent5" accent6="accent6" hlink="hlink" folHlink="folHlink"/>
-  <p:notesStyle>
-    <a:lvl1pPr marL="0" algn="l" defTabSz="457200" rtl="0" eaLnBrk="1" latinLnBrk="0" hangingPunct="1">
-      <a:defRPr sz="1200" kern="1200">
-        <a:solidFill>
-          <a:schemeClr val="tx1"/>
-        </a:solidFill>
-        <a:latin typeface="+mn-lt"/>
-        <a:ea typeface="+mn-ea"/>
-        <a:cs typeface="+mn-cs"/>
-      </a:defRPr>
-    </a:lvl1pPr>
-    <a:lvl2pPr marL="457200" algn="l" defTabSz="457200" rtl="0" eaLnBrk="1" latinLnBrk="0" hangingPunct="1">
-      <a:defRPr sz="1200" kern="1200">
-        <a:solidFill>
-          <a:schemeClr val="tx1"/>
-        </a:solidFill>
-        <a:latin typeface="+mn-lt"/>
-        <a:ea typeface="+mn-ea"/>
-        <a:cs typeface="+mn-cs"/>
-      </a:defRPr>
-    </a:lvl2pPr>
-    <a:lvl3pPr marL="914400" algn="l" defTabSz="457200" rtl="0" eaLnBrk="1" latinLnBrk="0" hangingPunct="1">
-      <a:defRPr sz="1200" kern="1200">
-        <a:solidFill>
-          <a:schemeClr val="tx1"/>
-        </a:solidFill>
-        <a:latin typeface="+mn-lt"/>
-        <a:ea typeface="+mn-ea"/>
-        <a:cs typeface="+mn-cs"/>
-      </a:defRPr>
-    </a:lvl3pPr>
-    <a:lvl4pPr marL="1371600" algn="l" defTabSz="457200" rtl="0" eaLnBrk="1" latinLnBrk="0" hangingPunct="1">
-      <a:defRPr sz="1200" kern="1200">
-        <a:solidFill>
-          <a:schemeClr val="tx1"/>
-        </a:solidFill>
-        <a:latin typeface="+mn-lt"/>
-        <a:ea typeface="+mn-ea"/>
-        <a:cs typeface="+mn-cs"/>
-      </a:defRPr>
-    </a:lvl4pPr>
-    <a:lvl5pPr marL="1828800" algn="l" defTabSz="457200" rtl="0" eaLnBrk="1" latinLnBrk="0" hangingPunct="1">
-      <a:defRPr sz="1200" kern="1200">
-        <a:solidFill>
-          <a:schemeClr val="tx1"/>
-        </a:solidFill>
-        <a:latin typeface="+mn-lt"/>
-        <a:ea typeface="+mn-ea"/>
-        <a:cs typeface="+mn-cs"/>
-      </a:defRPr>
-    </a:lvl5pPr>
-    <a:lvl6pPr marL="2286000" algn="l" defTabSz="457200" rtl="0" eaLnBrk="1" latinLnBrk="0" hangingPunct="1">
-      <a:defRPr sz="1200" kern="1200">
-        <a:solidFill>
-          <a:schemeClr val="tx1"/>
-        </a:solidFill>
-        <a:latin typeface="+mn-lt"/>
-        <a:ea typeface="+mn-ea"/>
-        <a:cs typeface="+mn-cs"/>
-      </a:defRPr>
-    </a:lvl6pPr>
-    <a:lvl7pPr marL="2743200" algn="l" defTabSz="457200" rtl="0" eaLnBrk="1" latinLnBrk="0" hangingPunct="1">
-      <a:defRPr sz="1200" kern="1200">
-        <a:solidFill>
-          <a:schemeClr val="tx1"/>
-        </a:solidFill>
-        <a:latin typeface="+mn-lt"/>
-        <a:ea typeface="+mn-ea"/>
-        <a:cs typeface="+mn-cs"/>
-      </a:defRPr>
-    </a:lvl7pPr>
-    <a:lvl8pPr marL="3200400" algn="l" defTabSz="457200" rtl="0" eaLnBrk="1" latinLnBrk="0" hangingPunct="1">
-      <a:defRPr sz="1200" kern="1200">
-        <a:solidFill>
-          <a:schemeClr val="tx1"/>
-        </a:solidFill>
-        <a:latin typeface="+mn-lt"/>
-        <a:ea typeface="+mn-ea"/>
-        <a:cs typeface="+mn-cs"/>
-      </a:defRPr>
-    </a:lvl8pPr>
-    <a:lvl9pPr marL="3657600" algn="l" defTabSz="457200" rtl="0" eaLnBrk="1" latinLnBrk="0" hangingPunct="1">
-      <a:defRPr sz="1200" kern="1200">
-        <a:solidFill>
-          <a:schemeClr val="tx1"/>
-        </a:solidFill>
-        <a:latin typeface="+mn-lt"/>
-        <a:ea typeface="+mn-ea"/>
-        <a:cs typeface="+mn-cs"/>
-      </a:defRPr>
-    </a:lvl9pPr>
-  </p:notesStyle>
-</p:notesMaster>
-</file>
-
-<file path=ppt/notesSlides/notesSlide1.xml><?xml version="1.0" encoding="utf-8"?>
-<p:notes xmlns:a="http://schemas.openxmlformats.org/drawingml/2006/main" xmlns:p="http://schemas.openxmlformats.org/presentationml/2006/main" xmlns:r="http://schemas.openxmlformats.org/officeDocument/2006/relationships">
-  <p:cSld>
-    <p:spTree>
-      <p:nvGrpSpPr>
-        <p:cNvPr id="1" name=""/>
-        <p:cNvGrpSpPr/>
-        <p:nvPr/>
-      </p:nvGrpSpPr>
-      <p:grpSpPr>
-        <a:xfrm>
-          <a:off x="0" y="0"/>
-          <a:ext cx="0" cy="0"/>
-          <a:chOff x="0" y="0"/>
-          <a:chExt cx="0" cy="0"/>
-        </a:xfrm>
-      </p:grpSpPr>
-      <p:sp>
-        <p:nvSpPr>
-          <p:cNvPr id="2" name="Slide Image Placeholder 1"/>
-          <p:cNvSpPr>
-            <a:spLocks noGrp="1"/>
-          </p:cNvSpPr>
-          <p:nvPr>
-            <p:ph type="sldImg" idx="2"/>
-          </p:nvPr>
-        </p:nvSpPr>
-        <p:spPr/>
-      </p:sp>
-      <p:sp>
-        <p:nvSpPr>
-          <p:cNvPr id="3" name="Notes Placeholder 2"/>
-          <p:cNvSpPr>
-            <a:spLocks noGrp="1"/>
-          </p:cNvSpPr>
-          <p:nvPr>
-            <p:ph type="body" idx="3" sz="quarter"/>
-          </p:nvPr>
-        </p:nvSpPr>
-        <p:spPr/>
-        <p:txBody>
-          <a:bodyPr/>
-          <a:lstStyle/>
-          <a:p>
-            <a:r>
-              <a:t>Не начинать с оргвопросов. Оргблок стоит в конце: на первой лекции внимание самое дорогое в первые двадцать минут, и тратить его на порядок сдачи работ не стоит.</a:t>
-            </a:r>
-          </a:p>
-        </p:txBody>
-      </p:sp>
-      <p:sp>
-        <p:nvSpPr>
-          <p:cNvPr id="4" name="Slide Number Placeholder 3"/>
-          <p:cNvSpPr>
-            <a:spLocks noGrp="1"/>
-          </p:cNvSpPr>
-          <p:nvPr>
-            <p:ph type="sldNum" idx="5" sz="quarter"/>
-          </p:nvPr>
-        </p:nvSpPr>
-        <p:spPr/>
-      </p:sp>
-    </p:spTree>
-  </p:cSld>
-  <p:clrMapOvr>
-    <a:masterClrMapping/>
-  </p:clrMapOvr>
-</p:notes>
-</file>
-
-<file path=ppt/notesSlides/notesSlide10.xml><?xml version="1.0" encoding="utf-8"?>
-<p:notes xmlns:a="http://schemas.openxmlformats.org/drawingml/2006/main" xmlns:p="http://schemas.openxmlformats.org/presentationml/2006/main" xmlns:r="http://schemas.openxmlformats.org/officeDocument/2006/relationships">
-  <p:cSld>
-    <p:spTree>
-      <p:nvGrpSpPr>
-        <p:cNvPr id="1" name=""/>
-        <p:cNvGrpSpPr/>
-        <p:nvPr/>
-      </p:nvGrpSpPr>
-      <p:grpSpPr>
-        <a:xfrm>
-          <a:off x="0" y="0"/>
-          <a:ext cx="0" cy="0"/>
-          <a:chOff x="0" y="0"/>
-          <a:chExt cx="0" cy="0"/>
-        </a:xfrm>
-      </p:grpSpPr>
-      <p:sp>
-        <p:nvSpPr>
-          <p:cNvPr id="2" name="Slide Image Placeholder 1"/>
-          <p:cNvSpPr>
-            <a:spLocks noGrp="1"/>
-          </p:cNvSpPr>
-          <p:nvPr>
-            <p:ph type="sldImg" idx="2"/>
-          </p:nvPr>
-        </p:nvSpPr>
-        <p:spPr/>
-      </p:sp>
-      <p:sp>
-        <p:nvSpPr>
-          <p:cNvPr id="3" name="Notes Placeholder 2"/>
-          <p:cNvSpPr>
-            <a:spLocks noGrp="1"/>
-          </p:cNvSpPr>
-          <p:nvPr>
-            <p:ph type="body" idx="3" sz="quarter"/>
-          </p:nvPr>
-        </p:nvSpPr>
-        <p:spPr/>
-        <p:txBody>
-          <a:bodyPr/>
-          <a:lstStyle/>
-          <a:p>
-            <a:r>
-              <a:t>Главное, что должен унести студент: у дисциплины есть согласованный состав, зафиксированный международным профессиональным сообществом, и он шире, чем «писать код». Конкретные названия областей заучивать не нужно — нужно знать, что карта существует и где посмотреть.</a:t>
-            </a:r>
-          </a:p>
-          <a:p/>
-          <a:p>
-            <a:r>
-              <a:t>Скажите прямо, что мы пройдём не всё и что именно останется за рамками. Признание границ курса на первой лекции снимает половину претензий на зачёте.</a:t>
-            </a:r>
-          </a:p>
-          <a:p/>
-          <a:p>
-            <a:r>
-              <a:t>ПЕРЕД ПОКАЗОМ: сверьте состав областей по оригиналу v4. На слайд идёт список, и ошибка в нём заметна.</a:t>
-            </a:r>
-          </a:p>
-        </p:txBody>
-      </p:sp>
-      <p:sp>
-        <p:nvSpPr>
-          <p:cNvPr id="4" name="Slide Number Placeholder 3"/>
-          <p:cNvSpPr>
-            <a:spLocks noGrp="1"/>
-          </p:cNvSpPr>
-          <p:nvPr>
-            <p:ph type="sldNum" idx="5" sz="quarter"/>
-          </p:nvPr>
-        </p:nvSpPr>
-        <p:spPr/>
-      </p:sp>
-    </p:spTree>
-  </p:cSld>
-  <p:clrMapOvr>
-    <a:masterClrMapping/>
-  </p:clrMapOvr>
-</p:notes>
-</file>
-
-<file path=ppt/notesSlides/notesSlide11.xml><?xml version="1.0" encoding="utf-8"?>
-<p:notes xmlns:a="http://schemas.openxmlformats.org/drawingml/2006/main" xmlns:p="http://schemas.openxmlformats.org/presentationml/2006/main" xmlns:r="http://schemas.openxmlformats.org/officeDocument/2006/relationships">
-  <p:cSld>
-    <p:spTree>
-      <p:nvGrpSpPr>
-        <p:cNvPr id="1" name=""/>
-        <p:cNvGrpSpPr/>
-        <p:nvPr/>
-      </p:nvGrpSpPr>
-      <p:grpSpPr>
-        <a:xfrm>
-          <a:off x="0" y="0"/>
-          <a:ext cx="0" cy="0"/>
-          <a:chOff x="0" y="0"/>
-          <a:chExt cx="0" cy="0"/>
-        </a:xfrm>
-      </p:grpSpPr>
-      <p:sp>
-        <p:nvSpPr>
-          <p:cNvPr id="2" name="Slide Image Placeholder 1"/>
-          <p:cNvSpPr>
-            <a:spLocks noGrp="1"/>
-          </p:cNvSpPr>
-          <p:nvPr>
-            <p:ph type="sldImg" idx="2"/>
-          </p:nvPr>
-        </p:nvSpPr>
-        <p:spPr/>
-      </p:sp>
-      <p:sp>
-        <p:nvSpPr>
-          <p:cNvPr id="3" name="Notes Placeholder 2"/>
-          <p:cNvSpPr>
-            <a:spLocks noGrp="1"/>
-          </p:cNvSpPr>
-          <p:nvPr>
-            <p:ph type="body" idx="3" sz="quarter"/>
-          </p:nvPr>
-        </p:nvSpPr>
-        <p:spPr/>
-        <p:txBody>
-          <a:bodyPr/>
-          <a:lstStyle/>
-          <a:p>
-            <a:r>
-              <a:t>Слайд делает две вещи сразу.</a:t>
-            </a:r>
-          </a:p>
-          <a:p/>
-          <a:p>
-            <a:r>
-              <a:t>Первая: показывает, что дисциплина живая. За десять лет свод знаний признал архитектуру и эксплуатацию самостоятельными областями — то есть отрасль пересмотрела, что входит в работу инженера. Хорошая иллюстрация к тому, что учебная программа не может быть написана один раз.</a:t>
-            </a:r>
-          </a:p>
-          <a:p/>
-          <a:p>
-            <a:r>
-              <a:t>Вторая, прагматичная: связывает два семестра. Скажите, что разделение осознанное: первый семестр — как работа организуется, специфицируется, проверяется, поставляется и эксплуатируется; второй — как система устроена внутри.</a:t>
-            </a:r>
-          </a:p>
-          <a:p/>
-          <a:p>
-            <a:r>
-              <a:t>Про Software Security оговорите, что отдельной лекции по безопасности в курсе нет, она проходит фрагментами — в DevSecOps и в атрибутах качества второго семестра.</a:t>
-            </a:r>
-          </a:p>
-        </p:txBody>
-      </p:sp>
-      <p:sp>
-        <p:nvSpPr>
-          <p:cNvPr id="4" name="Slide Number Placeholder 3"/>
-          <p:cNvSpPr>
-            <a:spLocks noGrp="1"/>
-          </p:cNvSpPr>
-          <p:nvPr>
-            <p:ph type="sldNum" idx="5" sz="quarter"/>
-          </p:nvPr>
-        </p:nvSpPr>
-        <p:spPr/>
-      </p:sp>
-    </p:spTree>
-  </p:cSld>
-  <p:clrMapOvr>
-    <a:masterClrMapping/>
-  </p:clrMapOvr>
-</p:notes>
-</file>
-
-<file path=ppt/notesSlides/notesSlide12.xml><?xml version="1.0" encoding="utf-8"?>
-<p:notes xmlns:a="http://schemas.openxmlformats.org/drawingml/2006/main" xmlns:p="http://schemas.openxmlformats.org/presentationml/2006/main" xmlns:r="http://schemas.openxmlformats.org/officeDocument/2006/relationships">
-  <p:cSld>
-    <p:spTree>
-      <p:nvGrpSpPr>
-        <p:cNvPr id="1" name=""/>
-        <p:cNvGrpSpPr/>
-        <p:nvPr/>
-      </p:nvGrpSpPr>
-      <p:grpSpPr>
-        <a:xfrm>
-          <a:off x="0" y="0"/>
-          <a:ext cx="0" cy="0"/>
-          <a:chOff x="0" y="0"/>
-          <a:chExt cx="0" cy="0"/>
-        </a:xfrm>
-      </p:grpSpPr>
-      <p:sp>
-        <p:nvSpPr>
-          <p:cNvPr id="2" name="Slide Image Placeholder 1"/>
-          <p:cNvSpPr>
-            <a:spLocks noGrp="1"/>
-          </p:cNvSpPr>
-          <p:nvPr>
-            <p:ph type="sldImg" idx="2"/>
-          </p:nvPr>
-        </p:nvSpPr>
-        <p:spPr/>
-      </p:sp>
-      <p:sp>
-        <p:nvSpPr>
-          <p:cNvPr id="3" name="Notes Placeholder 2"/>
-          <p:cNvSpPr>
-            <a:spLocks noGrp="1"/>
-          </p:cNvSpPr>
-          <p:nvPr>
-            <p:ph type="body" idx="3" sz="quarter"/>
-          </p:nvPr>
-        </p:nvSpPr>
-        <p:spPr/>
-        <p:txBody>
-          <a:bodyPr/>
-          <a:lstStyle/>
-          <a:p>
-            <a:r>
-              <a:t>Не зачитывайте таблицу — она нужна глазами. Скажите одно: набор стадий примерно один и тот же, отличаются границы и словарь.</a:t>
-            </a:r>
-          </a:p>
-          <a:p/>
-          <a:p>
-            <a:r>
-              <a:t>Обратите внимание группы на последнюю строку. Вывод из эксплуатации есть во всех трёх моделях, и это единственная стадия, которую студенты никогда не закладывают в свои проекты. Хороший момент, чтобы спросить: «Кто из вас, проектируя что-нибудь, думал о том, как это будет выключаться?»</a:t>
-            </a:r>
-          </a:p>
-          <a:p/>
-          <a:p>
-            <a:r>
-              <a:t>Стадии в колонках сверьте по действующим редакциям. Oracle CDM из старого слайда убран — методология не поддерживается.</a:t>
-            </a:r>
-          </a:p>
-        </p:txBody>
-      </p:sp>
-      <p:sp>
-        <p:nvSpPr>
-          <p:cNvPr id="4" name="Slide Number Placeholder 3"/>
-          <p:cNvSpPr>
-            <a:spLocks noGrp="1"/>
-          </p:cNvSpPr>
-          <p:nvPr>
-            <p:ph type="sldNum" idx="5" sz="quarter"/>
-          </p:nvPr>
-        </p:nvSpPr>
-        <p:spPr/>
-      </p:sp>
-    </p:spTree>
-  </p:cSld>
-  <p:clrMapOvr>
-    <a:masterClrMapping/>
-  </p:clrMapOvr>
-</p:notes>
-</file>
-
-<file path=ppt/notesSlides/notesSlide13.xml><?xml version="1.0" encoding="utf-8"?>
-<p:notes xmlns:a="http://schemas.openxmlformats.org/drawingml/2006/main" xmlns:p="http://schemas.openxmlformats.org/presentationml/2006/main" xmlns:r="http://schemas.openxmlformats.org/officeDocument/2006/relationships">
-  <p:cSld>
-    <p:spTree>
-      <p:nvGrpSpPr>
-        <p:cNvPr id="1" name=""/>
-        <p:cNvGrpSpPr/>
-        <p:nvPr/>
-      </p:nvGrpSpPr>
-      <p:grpSpPr>
-        <a:xfrm>
-          <a:off x="0" y="0"/>
-          <a:ext cx="0" cy="0"/>
-          <a:chOff x="0" y="0"/>
-          <a:chExt cx="0" cy="0"/>
-        </a:xfrm>
-      </p:grpSpPr>
-      <p:sp>
-        <p:nvSpPr>
-          <p:cNvPr id="2" name="Slide Image Placeholder 1"/>
-          <p:cNvSpPr>
-            <a:spLocks noGrp="1"/>
-          </p:cNvSpPr>
-          <p:nvPr>
-            <p:ph type="sldImg" idx="2"/>
-          </p:nvPr>
-        </p:nvSpPr>
-        <p:spPr/>
-      </p:sp>
-      <p:sp>
-        <p:nvSpPr>
-          <p:cNvPr id="3" name="Notes Placeholder 2"/>
-          <p:cNvSpPr>
-            <a:spLocks noGrp="1"/>
-          </p:cNvSpPr>
-          <p:nvPr>
-            <p:ph type="body" idx="3" sz="quarter"/>
-          </p:nvPr>
-        </p:nvSpPr>
-        <p:spPr/>
-        <p:txBody>
-          <a:bodyPr/>
-          <a:lstStyle/>
-          <a:p>
-            <a:r>
-              <a:t>Слайд снимает типовое заблуждение: студенты выходят с представлением, что ISO 12207 — это водопад и что стандарт что-то запрещает. Стандарт описывает состав работ, а не их расписание.</a:t>
-            </a:r>
-          </a:p>
-          <a:p/>
-          <a:p>
-            <a:r>
-              <a:t>Здесь же уместно вернуть четыре вопроса и показать, что они работают: выбор модели разработки — ровно то решение, у которого есть цена, отвергнутая альтернатива, признак ошибки и ответственный.</a:t>
-            </a:r>
-          </a:p>
-        </p:txBody>
-      </p:sp>
-      <p:sp>
-        <p:nvSpPr>
-          <p:cNvPr id="4" name="Slide Number Placeholder 3"/>
-          <p:cNvSpPr>
-            <a:spLocks noGrp="1"/>
-          </p:cNvSpPr>
-          <p:nvPr>
-            <p:ph type="sldNum" idx="5" sz="quarter"/>
-          </p:nvPr>
-        </p:nvSpPr>
-        <p:spPr/>
-      </p:sp>
-    </p:spTree>
-  </p:cSld>
-  <p:clrMapOvr>
-    <a:masterClrMapping/>
-  </p:clrMapOvr>
-</p:notes>
-</file>
-
-<file path=ppt/notesSlides/notesSlide14.xml><?xml version="1.0" encoding="utf-8"?>
-<p:notes xmlns:a="http://schemas.openxmlformats.org/drawingml/2006/main" xmlns:p="http://schemas.openxmlformats.org/presentationml/2006/main" xmlns:r="http://schemas.openxmlformats.org/officeDocument/2006/relationships">
-  <p:cSld>
-    <p:spTree>
-      <p:nvGrpSpPr>
-        <p:cNvPr id="1" name=""/>
-        <p:cNvGrpSpPr/>
-        <p:nvPr/>
-      </p:nvGrpSpPr>
-      <p:grpSpPr>
-        <a:xfrm>
-          <a:off x="0" y="0"/>
-          <a:ext cx="0" cy="0"/>
-          <a:chOff x="0" y="0"/>
-          <a:chExt cx="0" cy="0"/>
-        </a:xfrm>
-      </p:grpSpPr>
-      <p:sp>
-        <p:nvSpPr>
-          <p:cNvPr id="2" name="Slide Image Placeholder 1"/>
-          <p:cNvSpPr>
-            <a:spLocks noGrp="1"/>
-          </p:cNvSpPr>
-          <p:nvPr>
-            <p:ph type="sldImg" idx="2"/>
-          </p:nvPr>
-        </p:nvSpPr>
-        <p:spPr/>
-      </p:sp>
-      <p:sp>
-        <p:nvSpPr>
-          <p:cNvPr id="3" name="Notes Placeholder 2"/>
-          <p:cNvSpPr>
-            <a:spLocks noGrp="1"/>
-          </p:cNvSpPr>
-          <p:nvPr>
-            <p:ph type="body" idx="3" sz="quarter"/>
-          </p:nvPr>
-        </p:nvSpPr>
-        <p:spPr/>
-        <p:txBody>
-          <a:bodyPr/>
-          <a:lstStyle/>
-          <a:p>
-            <a:r>
-              <a:t>Пройдите по колонкам быстро, по одной фразе на пункт — это оглавление, а не содержание.</a:t>
-            </a:r>
-          </a:p>
-          <a:p/>
-          <a:p>
-            <a:r>
-              <a:t>Два места, где стоит задержаться на пятнадцать секунд:</a:t>
-            </a:r>
-          </a:p>
-          <a:p>
-            <a:r>
-              <a:t>— лекция 4, оценка: «мы разберём, почему оценки систематически занижены и что с этим делают»;</a:t>
-            </a:r>
-          </a:p>
-          <a:p>
-            <a:r>
-              <a:t>— лекция 5, конфигурации: «это то, чем вы будете заниматься каждый рабочий день с первого дня, и единственная тема, после которой останется навык, а не понимание».</a:t>
-            </a:r>
-          </a:p>
-          <a:p/>
-          <a:p>
-            <a:r>
-              <a:t>Скажите, что расписание тем может немного сдвинуться. Это правда, и лучше сказать заранее, чем объясняться в ноябре.</a:t>
-            </a:r>
-          </a:p>
-        </p:txBody>
-      </p:sp>
-      <p:sp>
-        <p:nvSpPr>
-          <p:cNvPr id="4" name="Slide Number Placeholder 3"/>
-          <p:cNvSpPr>
-            <a:spLocks noGrp="1"/>
-          </p:cNvSpPr>
-          <p:nvPr>
-            <p:ph type="sldNum" idx="5" sz="quarter"/>
-          </p:nvPr>
-        </p:nvSpPr>
-        <p:spPr/>
-      </p:sp>
-    </p:spTree>
-  </p:cSld>
-  <p:clrMapOvr>
-    <a:masterClrMapping/>
-  </p:clrMapOvr>
-</p:notes>
-</file>
-
-<file path=ppt/notesSlides/notesSlide15.xml><?xml version="1.0" encoding="utf-8"?>
-<p:notes xmlns:a="http://schemas.openxmlformats.org/drawingml/2006/main" xmlns:p="http://schemas.openxmlformats.org/presentationml/2006/main" xmlns:r="http://schemas.openxmlformats.org/officeDocument/2006/relationships">
-  <p:cSld>
-    <p:spTree>
-      <p:nvGrpSpPr>
-        <p:cNvPr id="1" name=""/>
-        <p:cNvGrpSpPr/>
-        <p:nvPr/>
-      </p:nvGrpSpPr>
-      <p:grpSpPr>
-        <a:xfrm>
-          <a:off x="0" y="0"/>
-          <a:ext cx="0" cy="0"/>
-          <a:chOff x="0" y="0"/>
-          <a:chExt cx="0" cy="0"/>
-        </a:xfrm>
-      </p:grpSpPr>
-      <p:sp>
-        <p:nvSpPr>
-          <p:cNvPr id="2" name="Slide Image Placeholder 1"/>
-          <p:cNvSpPr>
-            <a:spLocks noGrp="1"/>
-          </p:cNvSpPr>
-          <p:nvPr>
-            <p:ph type="sldImg" idx="2"/>
-          </p:nvPr>
-        </p:nvSpPr>
-        <p:spPr/>
-      </p:sp>
-      <p:sp>
-        <p:nvSpPr>
-          <p:cNvPr id="3" name="Notes Placeholder 2"/>
-          <p:cNvSpPr>
-            <a:spLocks noGrp="1"/>
-          </p:cNvSpPr>
-          <p:nvPr>
-            <p:ph type="body" idx="3" sz="quarter"/>
-          </p:nvPr>
-        </p:nvSpPr>
-        <p:spPr/>
-        <p:txBody>
-          <a:bodyPr/>
-          <a:lstStyle/>
-          <a:p>
-            <a:r>
-              <a:t>Оргблок в конце сознательно: к этому моменту студент уже понимает, о чём курс, и правила ложатся на содержание, а не в пустоту.</a:t>
-            </a:r>
-          </a:p>
-          <a:p/>
-          <a:p>
-            <a:r>
-              <a:t>Одна вещь, которую стоит сказать прямо на первой лекции: семинары в разных группах могут идти по-разному, а лекции и итоговый контроль — общие. Это снимает вопрос «а почему у них по-другому», который иначе всплывёт в октябре в неудобный момент.</a:t>
-            </a:r>
-          </a:p>
-          <a:p/>
-          <a:p>
-            <a:r>
-              <a:t>Финал — возврат к четырём вопросам.</a:t>
-            </a:r>
-          </a:p>
-        </p:txBody>
-      </p:sp>
-      <p:sp>
-        <p:nvSpPr>
-          <p:cNvPr id="4" name="Slide Number Placeholder 3"/>
-          <p:cNvSpPr>
-            <a:spLocks noGrp="1"/>
-          </p:cNvSpPr>
-          <p:nvPr>
-            <p:ph type="sldNum" idx="5" sz="quarter"/>
-          </p:nvPr>
-        </p:nvSpPr>
-        <p:spPr/>
-      </p:sp>
-    </p:spTree>
-  </p:cSld>
-  <p:clrMapOvr>
-    <a:masterClrMapping/>
-  </p:clrMapOvr>
-</p:notes>
-</file>
-
-<file path=ppt/notesSlides/notesSlide2.xml><?xml version="1.0" encoding="utf-8"?>
-<p:notes xmlns:a="http://schemas.openxmlformats.org/drawingml/2006/main" xmlns:p="http://schemas.openxmlformats.org/presentationml/2006/main" xmlns:r="http://schemas.openxmlformats.org/officeDocument/2006/relationships">
-  <p:cSld>
-    <p:spTree>
-      <p:nvGrpSpPr>
-        <p:cNvPr id="1" name=""/>
-        <p:cNvGrpSpPr/>
-        <p:nvPr/>
-      </p:nvGrpSpPr>
-      <p:grpSpPr>
-        <a:xfrm>
-          <a:off x="0" y="0"/>
-          <a:ext cx="0" cy="0"/>
-          <a:chOff x="0" y="0"/>
-          <a:chExt cx="0" cy="0"/>
-        </a:xfrm>
-      </p:grpSpPr>
-      <p:sp>
-        <p:nvSpPr>
-          <p:cNvPr id="2" name="Slide Image Placeholder 1"/>
-          <p:cNvSpPr>
-            <a:spLocks noGrp="1"/>
-          </p:cNvSpPr>
-          <p:nvPr>
-            <p:ph type="sldImg" idx="2"/>
-          </p:nvPr>
-        </p:nvSpPr>
-        <p:spPr/>
-      </p:sp>
-      <p:sp>
-        <p:nvSpPr>
-          <p:cNvPr id="3" name="Notes Placeholder 2"/>
-          <p:cNvSpPr>
-            <a:spLocks noGrp="1"/>
-          </p:cNvSpPr>
-          <p:nvPr>
-            <p:ph type="body" idx="3" sz="quarter"/>
-          </p:nvPr>
-        </p:nvSpPr>
-        <p:spPr/>
-        <p:txBody>
-          <a:bodyPr/>
-          <a:lstStyle/>
-          <a:p>
-            <a:r>
-              <a:t>Не спрашивайте «кто лучше» — ответ очевиден и потому бесполезен. Спросите иначе: что из правой колонки нельзя увидеть в коде? Ничего из этого в коде не написано — ни цена, ни альтернатива, ни признак отказа, ни ответственный.</a:t>
-            </a:r>
-          </a:p>
-          <a:p/>
-          <a:p>
-            <a:r>
-              <a:t>Отсюда тезис лекции: программная инженерия — это не про то, как писать код. Код здесь одинаковый. Это про то, что стоит вокруг решения и делает его проверяемым.</a:t>
-            </a:r>
-          </a:p>
-          <a:p/>
-          <a:p>
-            <a:r>
-              <a:t>Если аудитория живая, можно добавить: в 2026 году левая колонка стоит дешевле, чем когда-либо. Именно поэтому разница между колонками стала видимой, а не академической. Но не разворачивайте это здесь — тема перетянет внимание на себя.</a:t>
-            </a:r>
-          </a:p>
-        </p:txBody>
-      </p:sp>
-      <p:sp>
-        <p:nvSpPr>
-          <p:cNvPr id="4" name="Slide Number Placeholder 3"/>
-          <p:cNvSpPr>
-            <a:spLocks noGrp="1"/>
-          </p:cNvSpPr>
-          <p:nvPr>
-            <p:ph type="sldNum" idx="5" sz="quarter"/>
-          </p:nvPr>
-        </p:nvSpPr>
-        <p:spPr/>
-      </p:sp>
-    </p:spTree>
-  </p:cSld>
-  <p:clrMapOvr>
-    <a:masterClrMapping/>
-  </p:clrMapOvr>
-</p:notes>
-</file>
-
-<file path=ppt/notesSlides/notesSlide3.xml><?xml version="1.0" encoding="utf-8"?>
-<p:notes xmlns:a="http://schemas.openxmlformats.org/drawingml/2006/main" xmlns:p="http://schemas.openxmlformats.org/presentationml/2006/main" xmlns:r="http://schemas.openxmlformats.org/officeDocument/2006/relationships">
-  <p:cSld>
-    <p:spTree>
-      <p:nvGrpSpPr>
-        <p:cNvPr id="1" name=""/>
-        <p:cNvGrpSpPr/>
-        <p:nvPr/>
-      </p:nvGrpSpPr>
-      <p:grpSpPr>
-        <a:xfrm>
-          <a:off x="0" y="0"/>
-          <a:ext cx="0" cy="0"/>
-          <a:chOff x="0" y="0"/>
-          <a:chExt cx="0" cy="0"/>
-        </a:xfrm>
-      </p:grpSpPr>
-      <p:sp>
-        <p:nvSpPr>
-          <p:cNvPr id="2" name="Slide Image Placeholder 1"/>
-          <p:cNvSpPr>
-            <a:spLocks noGrp="1"/>
-          </p:cNvSpPr>
-          <p:nvPr>
-            <p:ph type="sldImg" idx="2"/>
-          </p:nvPr>
-        </p:nvSpPr>
-        <p:spPr/>
-      </p:sp>
-      <p:sp>
-        <p:nvSpPr>
-          <p:cNvPr id="3" name="Notes Placeholder 2"/>
-          <p:cNvSpPr>
-            <a:spLocks noGrp="1"/>
-          </p:cNvSpPr>
-          <p:nvPr>
-            <p:ph type="body" idx="3" sz="quarter"/>
-          </p:nvPr>
-        </p:nvSpPr>
-        <p:spPr/>
-        <p:txBody>
-          <a:bodyPr/>
-          <a:lstStyle/>
-          <a:p>
-            <a:r>
-              <a:t>Четыре вопроса — сквозная рамка курса, к ним можно возвращаться на любой лекции. Проговорите, что ни на один нельзя ответить «потом»: цена, альтернатива и признак отказа определяются в момент принятия решения, а не когда что-то сломалось.</a:t>
-            </a:r>
-          </a:p>
-          <a:p/>
-          <a:p>
-            <a:r>
-              <a:t>Точное определение инженерии здесь сознательно не даю. Скажите об этом вслух: строгое определение и разбор, чем инженерия отличается от ремесла, будет во втором семестре. Это честно и снимает ощущение, что от них что-то утаили.</a:t>
-            </a:r>
-          </a:p>
-        </p:txBody>
-      </p:sp>
-      <p:sp>
-        <p:nvSpPr>
-          <p:cNvPr id="4" name="Slide Number Placeholder 3"/>
-          <p:cNvSpPr>
-            <a:spLocks noGrp="1"/>
-          </p:cNvSpPr>
-          <p:nvPr>
-            <p:ph type="sldNum" idx="5" sz="quarter"/>
-          </p:nvPr>
-        </p:nvSpPr>
-        <p:spPr/>
-      </p:sp>
-    </p:spTree>
-  </p:cSld>
-  <p:clrMapOvr>
-    <a:masterClrMapping/>
-  </p:clrMapOvr>
-</p:notes>
-</file>
-
-<file path=ppt/notesSlides/notesSlide4.xml><?xml version="1.0" encoding="utf-8"?>
-<p:notes xmlns:a="http://schemas.openxmlformats.org/drawingml/2006/main" xmlns:p="http://schemas.openxmlformats.org/presentationml/2006/main" xmlns:r="http://schemas.openxmlformats.org/officeDocument/2006/relationships">
-  <p:cSld>
-    <p:spTree>
-      <p:nvGrpSpPr>
-        <p:cNvPr id="1" name=""/>
-        <p:cNvGrpSpPr/>
-        <p:nvPr/>
-      </p:nvGrpSpPr>
-      <p:grpSpPr>
-        <a:xfrm>
-          <a:off x="0" y="0"/>
-          <a:ext cx="0" cy="0"/>
-          <a:chOff x="0" y="0"/>
-          <a:chExt cx="0" cy="0"/>
-        </a:xfrm>
-      </p:grpSpPr>
-      <p:sp>
-        <p:nvSpPr>
-          <p:cNvPr id="2" name="Slide Image Placeholder 1"/>
-          <p:cNvSpPr>
-            <a:spLocks noGrp="1"/>
-          </p:cNvSpPr>
-          <p:nvPr>
-            <p:ph type="sldImg" idx="2"/>
-          </p:nvPr>
-        </p:nvSpPr>
-        <p:spPr/>
-      </p:sp>
-      <p:sp>
-        <p:nvSpPr>
-          <p:cNvPr id="3" name="Notes Placeholder 2"/>
-          <p:cNvSpPr>
-            <a:spLocks noGrp="1"/>
-          </p:cNvSpPr>
-          <p:nvPr>
-            <p:ph type="body" idx="3" sz="quarter"/>
-          </p:nvPr>
-        </p:nvSpPr>
-        <p:spPr/>
-        <p:txBody>
-          <a:bodyPr/>
-          <a:lstStyle/>
-          <a:p>
-            <a:r>
-              <a:t>Тон не снисходительный: студенты сами пока работают как ремесленники, и это нормально для их этапа.</a:t>
-            </a:r>
-          </a:p>
-          <a:p/>
-          <a:p>
-            <a:r>
-              <a:t>Ключевой поворот: ремесленный подход отказывает не из-за низкого качества, а из-за МАСШТАБА. Пока систему держит в голове один человек, вкус работает. Когда система больше — нужен способ передавать решения и проверять их без автора.</a:t>
-            </a:r>
-          </a:p>
-          <a:p/>
-          <a:p>
-            <a:r>
-              <a:t>В определении задержитесь на «экономически обоснованных». Красивое, чистое, идеально спроектированное решение, стоившее вдвое дороже выигрыша, инженерным не является. Эту часть студенты пропускают.</a:t>
-            </a:r>
-          </a:p>
-        </p:txBody>
-      </p:sp>
-      <p:sp>
-        <p:nvSpPr>
-          <p:cNvPr id="4" name="Slide Number Placeholder 3"/>
-          <p:cNvSpPr>
-            <a:spLocks noGrp="1"/>
-          </p:cNvSpPr>
-          <p:nvPr>
-            <p:ph type="sldNum" idx="5" sz="quarter"/>
-          </p:nvPr>
-        </p:nvSpPr>
-        <p:spPr/>
-      </p:sp>
-    </p:spTree>
-  </p:cSld>
-  <p:clrMapOvr>
-    <a:masterClrMapping/>
-  </p:clrMapOvr>
-</p:notes>
-</file>
-
-<file path=ppt/notesSlides/notesSlide5.xml><?xml version="1.0" encoding="utf-8"?>
-<p:notes xmlns:a="http://schemas.openxmlformats.org/drawingml/2006/main" xmlns:p="http://schemas.openxmlformats.org/presentationml/2006/main" xmlns:r="http://schemas.openxmlformats.org/officeDocument/2006/relationships">
-  <p:cSld>
-    <p:spTree>
-      <p:nvGrpSpPr>
-        <p:cNvPr id="1" name=""/>
-        <p:cNvGrpSpPr/>
-        <p:nvPr/>
-      </p:nvGrpSpPr>
-      <p:grpSpPr>
-        <a:xfrm>
-          <a:off x="0" y="0"/>
-          <a:ext cx="0" cy="0"/>
-          <a:chOff x="0" y="0"/>
-          <a:chExt cx="0" cy="0"/>
-        </a:xfrm>
-      </p:grpSpPr>
-      <p:sp>
-        <p:nvSpPr>
-          <p:cNvPr id="2" name="Slide Image Placeholder 1"/>
-          <p:cNvSpPr>
-            <a:spLocks noGrp="1"/>
-          </p:cNvSpPr>
-          <p:nvPr>
-            <p:ph type="sldImg" idx="2"/>
-          </p:nvPr>
-        </p:nvSpPr>
-        <p:spPr/>
-      </p:sp>
-      <p:sp>
-        <p:nvSpPr>
-          <p:cNvPr id="3" name="Notes Placeholder 2"/>
-          <p:cNvSpPr>
-            <a:spLocks noGrp="1"/>
-          </p:cNvSpPr>
-          <p:nvPr>
-            <p:ph type="body" idx="3" sz="quarter"/>
-          </p:nvPr>
-        </p:nvSpPr>
-        <p:spPr/>
-        <p:txBody>
-          <a:bodyPr/>
-          <a:lstStyle/>
-          <a:p>
-            <a:r>
-              <a:t>Слайд объясняет, почему нельзя переносить в разработку привычки массового производства: стадии, передача между цехами, минимизация переделок. Это инструменты выпуска, а не инструменты исследования.</a:t>
-            </a:r>
-          </a:p>
-          <a:p/>
-          <a:p>
-            <a:r>
-              <a:t>Возражение: «а как же процессы и планирование?» Ответ: они нужны, но не как способ избежать переделок, а как способ организовать обучение. Переделка в проектировании — не брак, а результат.</a:t>
-            </a:r>
-          </a:p>
-          <a:p/>
-          <a:p>
-            <a:r>
-              <a:t>К этому вернёмся в теме 3, когда будем разбирать плановые и гибкие модели.</a:t>
-            </a:r>
-          </a:p>
-        </p:txBody>
-      </p:sp>
-      <p:sp>
-        <p:nvSpPr>
-          <p:cNvPr id="4" name="Slide Number Placeholder 3"/>
-          <p:cNvSpPr>
-            <a:spLocks noGrp="1"/>
-          </p:cNvSpPr>
-          <p:nvPr>
-            <p:ph type="sldNum" idx="5" sz="quarter"/>
-          </p:nvPr>
-        </p:nvSpPr>
-        <p:spPr/>
-      </p:sp>
-    </p:spTree>
-  </p:cSld>
-  <p:clrMapOvr>
-    <a:masterClrMapping/>
-  </p:clrMapOvr>
-</p:notes>
-</file>
-
-<file path=ppt/notesSlides/notesSlide6.xml><?xml version="1.0" encoding="utf-8"?>
-<p:notes xmlns:a="http://schemas.openxmlformats.org/drawingml/2006/main" xmlns:p="http://schemas.openxmlformats.org/presentationml/2006/main" xmlns:r="http://schemas.openxmlformats.org/officeDocument/2006/relationships">
-  <p:cSld>
-    <p:spTree>
-      <p:nvGrpSpPr>
-        <p:cNvPr id="1" name=""/>
-        <p:cNvGrpSpPr/>
-        <p:nvPr/>
-      </p:nvGrpSpPr>
-      <p:grpSpPr>
-        <a:xfrm>
-          <a:off x="0" y="0"/>
-          <a:ext cx="0" cy="0"/>
-          <a:chOff x="0" y="0"/>
-          <a:chExt cx="0" cy="0"/>
-        </a:xfrm>
-      </p:grpSpPr>
-      <p:sp>
-        <p:nvSpPr>
-          <p:cNvPr id="2" name="Slide Image Placeholder 1"/>
-          <p:cNvSpPr>
-            <a:spLocks noGrp="1"/>
-          </p:cNvSpPr>
-          <p:nvPr>
-            <p:ph type="sldImg" idx="2"/>
-          </p:nvPr>
-        </p:nvSpPr>
-        <p:spPr/>
-      </p:sp>
-      <p:sp>
-        <p:nvSpPr>
-          <p:cNvPr id="3" name="Notes Placeholder 2"/>
-          <p:cNvSpPr>
-            <a:spLocks noGrp="1"/>
-          </p:cNvSpPr>
-          <p:nvPr>
-            <p:ph type="body" idx="3" sz="quarter"/>
-          </p:nvPr>
-        </p:nvSpPr>
-        <p:spPr/>
-        <p:txBody>
-          <a:bodyPr/>
-          <a:lstStyle/>
-          <a:p>
-            <a:r>
-              <a:t>Короткий блок, 4–5 минут, не превращайте в историю вычислительной техники. Единственное, что должно остаться: дисциплина возникла не потому, что кто-то захотел красивую методологию, а потому, что проекты систематически не получались, и стало ясно, что причина не техническая.</a:t>
-            </a:r>
-          </a:p>
-          <a:p/>
-          <a:p>
-            <a:r>
-              <a:t>Про Гамильтон стоит сказать одну деталь: она вводила термин в том числе чтобы работу над ПО начали воспринимать всерьёз наравне с аппаратной инженерией.</a:t>
-            </a:r>
-          </a:p>
-          <a:p/>
-          <a:p>
-            <a:r>
-              <a:t>Переход к следующему слайду: «Если диагноз конференции верный — сложностью действительно не умеют управлять, — это должно быть видно в цифрах. Вот первая такая цифра, которую вы будете встречать всю жизнь».</a:t>
-            </a:r>
-          </a:p>
-        </p:txBody>
-      </p:sp>
-      <p:sp>
-        <p:nvSpPr>
-          <p:cNvPr id="4" name="Slide Number Placeholder 3"/>
-          <p:cNvSpPr>
-            <a:spLocks noGrp="1"/>
-          </p:cNvSpPr>
-          <p:nvPr>
-            <p:ph type="sldNum" idx="5" sz="quarter"/>
-          </p:nvPr>
-        </p:nvSpPr>
-        <p:spPr/>
-      </p:sp>
-    </p:spTree>
-  </p:cSld>
-  <p:clrMapOvr>
-    <a:masterClrMapping/>
-  </p:clrMapOvr>
-</p:notes>
-</file>
-
-<file path=ppt/notesSlides/notesSlide7.xml><?xml version="1.0" encoding="utf-8"?>
-<p:notes xmlns:a="http://schemas.openxmlformats.org/drawingml/2006/main" xmlns:p="http://schemas.openxmlformats.org/presentationml/2006/main" xmlns:r="http://schemas.openxmlformats.org/officeDocument/2006/relationships">
-  <p:cSld>
-    <p:spTree>
-      <p:nvGrpSpPr>
-        <p:cNvPr id="1" name=""/>
-        <p:cNvGrpSpPr/>
-        <p:nvPr/>
-      </p:nvGrpSpPr>
-      <p:grpSpPr>
-        <a:xfrm>
-          <a:off x="0" y="0"/>
-          <a:ext cx="0" cy="0"/>
-          <a:chOff x="0" y="0"/>
-          <a:chExt cx="0" cy="0"/>
-        </a:xfrm>
-      </p:grpSpPr>
-      <p:sp>
-        <p:nvSpPr>
-          <p:cNvPr id="2" name="Slide Image Placeholder 1"/>
-          <p:cNvSpPr>
-            <a:spLocks noGrp="1"/>
-          </p:cNvSpPr>
-          <p:nvPr>
-            <p:ph type="sldImg" idx="2"/>
-          </p:nvPr>
-        </p:nvSpPr>
-        <p:spPr/>
-      </p:sp>
-      <p:sp>
-        <p:nvSpPr>
-          <p:cNvPr id="3" name="Notes Placeholder 2"/>
-          <p:cNvSpPr>
-            <a:spLocks noGrp="1"/>
-          </p:cNvSpPr>
-          <p:nvPr>
-            <p:ph type="body" idx="3" sz="quarter"/>
-          </p:nvPr>
-        </p:nvSpPr>
-        <p:spPr/>
-        <p:txBody>
-          <a:bodyPr/>
-          <a:lstStyle/>
-          <a:p>
-            <a:r>
-              <a:t>Подайте всерьёз, без иронии — ирония сломает упражнение. Студент должен сначала принять цифру, как принимал её каждый, кто её цитировал.</a:t>
-            </a:r>
-          </a:p>
-          <a:p/>
-          <a:p>
-            <a:r>
-              <a:t>Честно скажите, что она стояла и в этом курсе, и вы её убираете. Это не самоуничижение: демонстрация того, что пересмотр собственных материалов — нормальная инженерная процедура, стоит больше, чем сама цифра.</a:t>
-            </a:r>
-          </a:p>
-          <a:p/>
-          <a:p>
-            <a:r>
-              <a:t>ВАЖНО: на слайде приведены цифры первого отчёта 1994 года. Если берёте другой год — замените и здесь, и в разборе на следующем слайде. Не смешивайте распределения разных лет: их расхождение работает как отдельный аргумент.</a:t>
-            </a:r>
-          </a:p>
-        </p:txBody>
-      </p:sp>
-      <p:sp>
-        <p:nvSpPr>
-          <p:cNvPr id="4" name="Slide Number Placeholder 3"/>
-          <p:cNvSpPr>
-            <a:spLocks noGrp="1"/>
-          </p:cNvSpPr>
-          <p:nvPr>
-            <p:ph type="sldNum" idx="5" sz="quarter"/>
-          </p:nvPr>
-        </p:nvSpPr>
-        <p:spPr/>
-      </p:sp>
-    </p:spTree>
-  </p:cSld>
-  <p:clrMapOvr>
-    <a:masterClrMapping/>
-  </p:clrMapOvr>
-</p:notes>
-</file>
-
-<file path=ppt/notesSlides/notesSlide8.xml><?xml version="1.0" encoding="utf-8"?>
-<p:notes xmlns:a="http://schemas.openxmlformats.org/drawingml/2006/main" xmlns:p="http://schemas.openxmlformats.org/presentationml/2006/main" xmlns:r="http://schemas.openxmlformats.org/officeDocument/2006/relationships">
-  <p:cSld>
-    <p:spTree>
-      <p:nvGrpSpPr>
-        <p:cNvPr id="1" name=""/>
-        <p:cNvGrpSpPr/>
-        <p:nvPr/>
-      </p:nvGrpSpPr>
-      <p:grpSpPr>
-        <a:xfrm>
-          <a:off x="0" y="0"/>
-          <a:ext cx="0" cy="0"/>
-          <a:chOff x="0" y="0"/>
-          <a:chExt cx="0" cy="0"/>
-        </a:xfrm>
-      </p:grpSpPr>
-      <p:sp>
-        <p:nvSpPr>
-          <p:cNvPr id="2" name="Slide Image Placeholder 1"/>
-          <p:cNvSpPr>
-            <a:spLocks noGrp="1"/>
-          </p:cNvSpPr>
-          <p:nvPr>
-            <p:ph type="sldImg" idx="2"/>
-          </p:nvPr>
-        </p:nvSpPr>
-        <p:spPr/>
-      </p:sp>
-      <p:sp>
-        <p:nvSpPr>
-          <p:cNvPr id="3" name="Notes Placeholder 2"/>
-          <p:cNvSpPr>
-            <a:spLocks noGrp="1"/>
-          </p:cNvSpPr>
-          <p:nvPr>
-            <p:ph type="body" idx="3" sz="quarter"/>
-          </p:nvPr>
-        </p:nvSpPr>
-        <p:spPr/>
-        <p:txBody>
-          <a:bodyPr/>
-          <a:lstStyle/>
-          <a:p>
-            <a:r>
-              <a:t>Это ядро лекции. Ведите к выводу вопросами, не давайте готовым.</a:t>
-            </a:r>
-          </a:p>
-          <a:p/>
-          <a:p>
-            <a:r>
-              <a:t>Спросите: «Компания сделала систему, она приносит прибыль, но вышла на два месяца позже плана. Успех или провал?» По определению — провал. Дайте паузу.</a:t>
-            </a:r>
-          </a:p>
-          <a:p/>
-          <a:p>
-            <a:r>
-              <a:t>Второй вопрос сильнее: «Как команде гарантированно попасть в категорию успешных?» Кто-нибудь дойдёт до ответа сам — заложить в оценку запас побольше. Вот здесь и надо остановиться: показатель, который улучшается от завышения оценок, измеряет не то, что написано на его этикетке.</a:t>
-            </a:r>
-          </a:p>
-          <a:p/>
-          <a:p>
-            <a:r>
-              <a:t>Переносимый навык: не «CHAOS плохой», а всегда проверяйте, что операционально измерено, прежде чем пользоваться выводом.</a:t>
-            </a:r>
-          </a:p>
-        </p:txBody>
-      </p:sp>
-      <p:sp>
-        <p:nvSpPr>
-          <p:cNvPr id="4" name="Slide Number Placeholder 3"/>
-          <p:cNvSpPr>
-            <a:spLocks noGrp="1"/>
-          </p:cNvSpPr>
-          <p:nvPr>
-            <p:ph type="sldNum" idx="5" sz="quarter"/>
-          </p:nvPr>
-        </p:nvSpPr>
-        <p:spPr/>
-      </p:sp>
-    </p:spTree>
-  </p:cSld>
-  <p:clrMapOvr>
-    <a:masterClrMapping/>
-  </p:clrMapOvr>
-</p:notes>
-</file>
-
-<file path=ppt/notesSlides/notesSlide9.xml><?xml version="1.0" encoding="utf-8"?>
-<p:notes xmlns:a="http://schemas.openxmlformats.org/drawingml/2006/main" xmlns:p="http://schemas.openxmlformats.org/presentationml/2006/main" xmlns:r="http://schemas.openxmlformats.org/officeDocument/2006/relationships">
-  <p:cSld>
-    <p:spTree>
-      <p:nvGrpSpPr>
-        <p:cNvPr id="1" name=""/>
-        <p:cNvGrpSpPr/>
-        <p:nvPr/>
-      </p:nvGrpSpPr>
-      <p:grpSpPr>
-        <a:xfrm>
-          <a:off x="0" y="0"/>
-          <a:ext cx="0" cy="0"/>
-          <a:chOff x="0" y="0"/>
-          <a:chExt cx="0" cy="0"/>
-        </a:xfrm>
-      </p:grpSpPr>
-      <p:sp>
-        <p:nvSpPr>
-          <p:cNvPr id="2" name="Slide Image Placeholder 1"/>
-          <p:cNvSpPr>
-            <a:spLocks noGrp="1"/>
-          </p:cNvSpPr>
-          <p:nvPr>
-            <p:ph type="sldImg" idx="2"/>
-          </p:nvPr>
-        </p:nvSpPr>
-        <p:spPr/>
-      </p:sp>
-      <p:sp>
-        <p:nvSpPr>
-          <p:cNvPr id="3" name="Notes Placeholder 2"/>
-          <p:cNvSpPr>
-            <a:spLocks noGrp="1"/>
-          </p:cNvSpPr>
-          <p:nvPr>
-            <p:ph type="body" idx="3" sz="quarter"/>
-          </p:nvPr>
-        </p:nvSpPr>
-        <p:spPr/>
-        <p:txBody>
-          <a:bodyPr/>
-          <a:lstStyle/>
-          <a:p>
-            <a:r>
-              <a:t>Последнюю строку произнесите вслух, она важнее остальных. Вы задаёте норму: в этом курсе можно спрашивать «откуда цифра», в том числе у лектора.</a:t>
-            </a:r>
-          </a:p>
-          <a:p/>
-          <a:p>
-            <a:r>
-              <a:t>Эти четыре вопроса — не те же самые, что на слайде 3. Там вопросы про решение (цена, альтернатива, признак отказа, кто решил), здесь — про измерение (что посчитано, на какой выборке, кому выгодно, воспроизводимо ли). Если аудитория готова, можно сказать это прямо: набор другой, а дисциплина та же — не полагаться на утверждение, не выяснив, на чём оно стоит.</a:t>
-            </a:r>
-          </a:p>
-          <a:p/>
-          <a:p>
-            <a:r>
-              <a:t>Здесь же анонсируйте семинар: студент берёт любое публичное утверждение о разработке ПО с числом — из статьи, из презентации вендора, из рекламы инструмента — и разбирает по этим четырём пунктам.</a:t>
-            </a:r>
-          </a:p>
-          <a:p/>
-          <a:p>
-            <a:r>
-              <a:t>Переход: «Мы поняли, как проверять утверждения о дисциплине. Теперь — из чего дисциплина состоит».</a:t>
-            </a:r>
-          </a:p>
-        </p:txBody>
-      </p:sp>
-      <p:sp>
-        <p:nvSpPr>
-          <p:cNvPr id="4" name="Slide Number Placeholder 3"/>
-          <p:cNvSpPr>
-            <a:spLocks noGrp="1"/>
-          </p:cNvSpPr>
-          <p:nvPr>
-            <p:ph type="sldNum" idx="5" sz="quarter"/>
-          </p:nvPr>
-        </p:nvSpPr>
-        <p:spPr/>
-      </p:sp>
-    </p:spTree>
-  </p:cSld>
-  <p:clrMapOvr>
-    <a:masterClrMapping/>
-  </p:clrMapOvr>
-</p:notes>
 </file>
 
 <file path=ppt/slideLayouts/slideLayout1.xml><?xml version="1.0" encoding="utf-8"?>

</xml_diff>